<commit_message>
fix: remplir/vider la table Blocs optionnels (object 53) avec les vraies slides optionnelles
- Les slides marquées optionnel:true dans slide-plans.json alimentent
  les 2 lignes de la table (max 2 blocs, 3 bullets chacun)
- Les lignes sans données sont vidées (plus de contenu exemple du template)
- Le déroulé exclut désormais les slides optionnelles de ses 6 étapes
</commit_message>
<xml_diff>
--- a/assets/fiches/A1-fiche.pptx
+++ b/assets/fiches/A1-fiche.pptx
@@ -6051,27 +6051,7 @@
                           <a:latin typeface="Arial"/>
                           <a:cs typeface="Arial"/>
                         </a:rPr>
-                        <a:t>15</a:t>
-                      </a:r>
-                      <a:r>
-                        <a:rPr sz="850" b="1" spc="-10" dirty="0">
-                          <a:solidFill>
-                            <a:srgbClr val="E67D21"/>
-                          </a:solidFill>
-                          <a:latin typeface="Arial"/>
-                          <a:cs typeface="Arial"/>
-                        </a:rPr>
-                        <a:t> </a:t>
-                      </a:r>
-                      <a:r>
-                        <a:rPr sz="850" b="1" spc="-25" dirty="0">
-                          <a:solidFill>
-                            <a:srgbClr val="E67D21"/>
-                          </a:solidFill>
-                          <a:latin typeface="Arial"/>
-                          <a:cs typeface="Arial"/>
-                        </a:rPr>
-                        <a:t>min</a:t>
+                        <a:t/>
                       </a:r>
                       <a:endParaRPr sz="850">
                         <a:latin typeface="Arial"/>
@@ -6092,7 +6072,7 @@
                           <a:latin typeface="Arial"/>
                           <a:cs typeface="Arial"/>
                         </a:rPr>
-                        <a:t>Teleconsultation</a:t>
+                        <a:t/>
                       </a:r>
                       <a:endParaRPr sz="1050">
                         <a:latin typeface="Arial"/>
@@ -6119,137 +6099,7 @@
                           <a:latin typeface="Arial"/>
                           <a:cs typeface="Arial"/>
                         </a:rPr>
-                        <a:t>OPT.</a:t>
-                      </a:r>
-                      <a:r>
-                        <a:rPr sz="1200" b="1" baseline="13888" dirty="0">
-                          <a:solidFill>
-                            <a:srgbClr val="FFFFFF"/>
-                          </a:solidFill>
-                          <a:latin typeface="Arial"/>
-                          <a:cs typeface="Arial"/>
-                        </a:rPr>
-                        <a:t>	</a:t>
-                      </a:r>
-                      <a:r>
-                        <a:rPr sz="900" dirty="0">
-                          <a:solidFill>
-                            <a:srgbClr val="2B2B2B"/>
-                          </a:solidFill>
-                          <a:latin typeface="Arial"/>
-                          <a:cs typeface="Arial"/>
-                        </a:rPr>
-                        <a:t>.</a:t>
-                      </a:r>
-                      <a:r>
-                        <a:rPr sz="900" spc="-5" dirty="0">
-                          <a:solidFill>
-                            <a:srgbClr val="2B2B2B"/>
-                          </a:solidFill>
-                          <a:latin typeface="Arial"/>
-                          <a:cs typeface="Arial"/>
-                        </a:rPr>
-                        <a:t> </a:t>
-                      </a:r>
-                      <a:r>
-                        <a:rPr sz="900" dirty="0">
-                          <a:solidFill>
-                            <a:srgbClr val="2B2B2B"/>
-                          </a:solidFill>
-                          <a:latin typeface="Arial"/>
-                          <a:cs typeface="Arial"/>
-                        </a:rPr>
-                        <a:t>Expliquer</a:t>
-                      </a:r>
-                      <a:r>
-                        <a:rPr sz="900" spc="-5" dirty="0">
-                          <a:solidFill>
-                            <a:srgbClr val="2B2B2B"/>
-                          </a:solidFill>
-                          <a:latin typeface="Arial"/>
-                          <a:cs typeface="Arial"/>
-                        </a:rPr>
-                        <a:t> </a:t>
-                      </a:r>
-                      <a:r>
-                        <a:rPr sz="900" dirty="0">
-                          <a:solidFill>
-                            <a:srgbClr val="2B2B2B"/>
-                          </a:solidFill>
-                          <a:latin typeface="Arial"/>
-                          <a:cs typeface="Arial"/>
-                        </a:rPr>
-                        <a:t>ce qu'est</a:t>
-                      </a:r>
-                      <a:r>
-                        <a:rPr sz="900" spc="-5" dirty="0">
-                          <a:solidFill>
-                            <a:srgbClr val="2B2B2B"/>
-                          </a:solidFill>
-                          <a:latin typeface="Arial"/>
-                          <a:cs typeface="Arial"/>
-                        </a:rPr>
-                        <a:t> </a:t>
-                      </a:r>
-                      <a:r>
-                        <a:rPr sz="900" dirty="0">
-                          <a:solidFill>
-                            <a:srgbClr val="2B2B2B"/>
-                          </a:solidFill>
-                          <a:latin typeface="Arial"/>
-                          <a:cs typeface="Arial"/>
-                        </a:rPr>
-                        <a:t>la teleconsultation</a:t>
-                      </a:r>
-                      <a:r>
-                        <a:rPr sz="900" spc="-5" dirty="0">
-                          <a:solidFill>
-                            <a:srgbClr val="2B2B2B"/>
-                          </a:solidFill>
-                          <a:latin typeface="Arial"/>
-                          <a:cs typeface="Arial"/>
-                        </a:rPr>
-                        <a:t> </a:t>
-                      </a:r>
-                      <a:r>
-                        <a:rPr sz="900" dirty="0">
-                          <a:solidFill>
-                            <a:srgbClr val="2B2B2B"/>
-                          </a:solidFill>
-                          <a:latin typeface="Arial"/>
-                          <a:cs typeface="Arial"/>
-                        </a:rPr>
-                        <a:t>et</a:t>
-                      </a:r>
-                      <a:r>
-                        <a:rPr sz="900" spc="-5" dirty="0">
-                          <a:solidFill>
-                            <a:srgbClr val="2B2B2B"/>
-                          </a:solidFill>
-                          <a:latin typeface="Arial"/>
-                          <a:cs typeface="Arial"/>
-                        </a:rPr>
-                        <a:t> </a:t>
-                      </a:r>
-                      <a:r>
-                        <a:rPr sz="900" dirty="0">
-                          <a:solidFill>
-                            <a:srgbClr val="2B2B2B"/>
-                          </a:solidFill>
-                          <a:latin typeface="Arial"/>
-                          <a:cs typeface="Arial"/>
-                        </a:rPr>
-                        <a:t>son </a:t>
-                      </a:r>
-                      <a:r>
-                        <a:rPr sz="900" spc="-10" dirty="0">
-                          <a:solidFill>
-                            <a:srgbClr val="2B2B2B"/>
-                          </a:solidFill>
-                          <a:latin typeface="Arial"/>
-                          <a:cs typeface="Arial"/>
-                        </a:rPr>
-                        <a:t>remboursement</a:t>
+                        <a:t/>
                       </a:r>
                       <a:endParaRPr sz="900">
                         <a:latin typeface="Arial"/>
@@ -6270,17 +6120,7 @@
                           <a:latin typeface="Arial"/>
                           <a:cs typeface="Arial"/>
                         </a:rPr>
-                        <a:t>. Montrer comment reperer un medecin proposant la </a:t>
-                      </a:r>
-                      <a:r>
-                        <a:rPr sz="900" spc="-10" dirty="0">
-                          <a:solidFill>
-                            <a:srgbClr val="2B2B2B"/>
-                          </a:solidFill>
-                          <a:latin typeface="Arial"/>
-                          <a:cs typeface="Arial"/>
-                        </a:rPr>
-                        <a:t>video</a:t>
+                        <a:t/>
                       </a:r>
                       <a:endParaRPr sz="900">
                         <a:latin typeface="Arial"/>
@@ -6301,17 +6141,7 @@
                           <a:latin typeface="Arial"/>
                           <a:cs typeface="Arial"/>
                         </a:rPr>
-                        <a:t>. Simuler la reception du lien et le demarrage de la </a:t>
-                      </a:r>
-                      <a:r>
-                        <a:rPr sz="900" spc="-10" dirty="0">
-                          <a:solidFill>
-                            <a:srgbClr val="2B2B2B"/>
-                          </a:solidFill>
-                          <a:latin typeface="Arial"/>
-                          <a:cs typeface="Arial"/>
-                        </a:rPr>
-                        <a:t>session</a:t>
+                        <a:t/>
                       </a:r>
                       <a:endParaRPr sz="900">
                         <a:latin typeface="Arial"/>
@@ -6374,27 +6204,7 @@
                           <a:latin typeface="Arial"/>
                           <a:cs typeface="Arial"/>
                         </a:rPr>
-                        <a:t>10</a:t>
-                      </a:r>
-                      <a:r>
-                        <a:rPr sz="850" b="1" spc="-10" dirty="0">
-                          <a:solidFill>
-                            <a:srgbClr val="E67D21"/>
-                          </a:solidFill>
-                          <a:latin typeface="Arial"/>
-                          <a:cs typeface="Arial"/>
-                        </a:rPr>
-                        <a:t> </a:t>
-                      </a:r>
-                      <a:r>
-                        <a:rPr sz="850" b="1" spc="-25" dirty="0">
-                          <a:solidFill>
-                            <a:srgbClr val="E67D21"/>
-                          </a:solidFill>
-                          <a:latin typeface="Arial"/>
-                          <a:cs typeface="Arial"/>
-                        </a:rPr>
-                        <a:t>min</a:t>
+                        <a:t/>
                       </a:r>
                       <a:endParaRPr sz="850">
                         <a:latin typeface="Arial"/>
@@ -6415,67 +6225,7 @@
                           <a:latin typeface="Arial"/>
                           <a:cs typeface="Arial"/>
                         </a:rPr>
-                        <a:t>Acceder</a:t>
-                      </a:r>
-                      <a:r>
-                        <a:rPr sz="1050" b="1" spc="-25" dirty="0">
-                          <a:solidFill>
-                            <a:srgbClr val="2B2B2B"/>
-                          </a:solidFill>
-                          <a:latin typeface="Arial"/>
-                          <a:cs typeface="Arial"/>
-                        </a:rPr>
-                        <a:t> </a:t>
-                      </a:r>
-                      <a:r>
-                        <a:rPr sz="1050" b="1" dirty="0">
-                          <a:solidFill>
-                            <a:srgbClr val="2B2B2B"/>
-                          </a:solidFill>
-                          <a:latin typeface="Arial"/>
-                          <a:cs typeface="Arial"/>
-                        </a:rPr>
-                        <a:t>a</a:t>
-                      </a:r>
-                      <a:r>
-                        <a:rPr sz="1050" b="1" spc="-25" dirty="0">
-                          <a:solidFill>
-                            <a:srgbClr val="2B2B2B"/>
-                          </a:solidFill>
-                          <a:latin typeface="Arial"/>
-                          <a:cs typeface="Arial"/>
-                        </a:rPr>
-                        <a:t> </a:t>
-                      </a:r>
-                      <a:r>
-                        <a:rPr sz="1050" b="1" dirty="0">
-                          <a:solidFill>
-                            <a:srgbClr val="2B2B2B"/>
-                          </a:solidFill>
-                          <a:latin typeface="Arial"/>
-                          <a:cs typeface="Arial"/>
-                        </a:rPr>
-                        <a:t>mes</a:t>
-                      </a:r>
-                      <a:r>
-                        <a:rPr sz="1050" b="1" spc="-20" dirty="0">
-                          <a:solidFill>
-                            <a:srgbClr val="2B2B2B"/>
-                          </a:solidFill>
-                          <a:latin typeface="Arial"/>
-                          <a:cs typeface="Arial"/>
-                        </a:rPr>
-                        <a:t> </a:t>
-                      </a:r>
-                      <a:r>
-                        <a:rPr sz="1050" b="1" spc="-10" dirty="0">
-                          <a:solidFill>
-                            <a:srgbClr val="2B2B2B"/>
-                          </a:solidFill>
-                          <a:latin typeface="Arial"/>
-                          <a:cs typeface="Arial"/>
-                        </a:rPr>
-                        <a:t>documents</a:t>
+                        <a:t/>
                       </a:r>
                       <a:endParaRPr sz="1050">
                         <a:latin typeface="Arial"/>
@@ -6502,37 +6252,7 @@
                           <a:latin typeface="Arial"/>
                           <a:cs typeface="Arial"/>
                         </a:rPr>
-                        <a:t>OPT.</a:t>
-                      </a:r>
-                      <a:r>
-                        <a:rPr sz="1200" b="1" baseline="13888" dirty="0">
-                          <a:solidFill>
-                            <a:srgbClr val="FFFFFF"/>
-                          </a:solidFill>
-                          <a:latin typeface="Arial"/>
-                          <a:cs typeface="Arial"/>
-                        </a:rPr>
-                        <a:t>	</a:t>
-                      </a:r>
-                      <a:r>
-                        <a:rPr sz="900" dirty="0">
-                          <a:solidFill>
-                            <a:srgbClr val="2B2B2B"/>
-                          </a:solidFill>
-                          <a:latin typeface="Arial"/>
-                          <a:cs typeface="Arial"/>
-                        </a:rPr>
-                        <a:t>. Naviguer vers Mon espace sante &gt; Mes </a:t>
-                      </a:r>
-                      <a:r>
-                        <a:rPr sz="900" spc="-10" dirty="0">
-                          <a:solidFill>
-                            <a:srgbClr val="2B2B2B"/>
-                          </a:solidFill>
-                          <a:latin typeface="Arial"/>
-                          <a:cs typeface="Arial"/>
-                        </a:rPr>
-                        <a:t>documents</a:t>
+                        <a:t/>
                       </a:r>
                       <a:endParaRPr sz="900">
                         <a:latin typeface="Arial"/>
@@ -6553,17 +6273,7 @@
                           <a:latin typeface="Arial"/>
                           <a:cs typeface="Arial"/>
                         </a:rPr>
-                        <a:t>. Retrouver une ordonnance ou un resultat </a:t>
-                      </a:r>
-                      <a:r>
-                        <a:rPr sz="900" spc="-10" dirty="0">
-                          <a:solidFill>
-                            <a:srgbClr val="2B2B2B"/>
-                          </a:solidFill>
-                          <a:latin typeface="Arial"/>
-                          <a:cs typeface="Arial"/>
-                        </a:rPr>
-                        <a:t>d'analyse</a:t>
+                        <a:t/>
                       </a:r>
                       <a:endParaRPr sz="900">
                         <a:latin typeface="Arial"/>
@@ -6584,17 +6294,7 @@
                           <a:latin typeface="Arial"/>
                           <a:cs typeface="Arial"/>
                         </a:rPr>
-                        <a:t>. Telecharger ou imprimer un document depuis </a:t>
-                      </a:r>
-                      <a:r>
-                        <a:rPr sz="900" spc="-10" dirty="0">
-                          <a:solidFill>
-                            <a:srgbClr val="2B2B2B"/>
-                          </a:solidFill>
-                          <a:latin typeface="Arial"/>
-                          <a:cs typeface="Arial"/>
-                        </a:rPr>
-                        <a:t>Doctolib</a:t>
+                        <a:t/>
                       </a:r>
                       <a:endParaRPr sz="900">
                         <a:latin typeface="Arial"/>

</xml_diff>

<commit_message>
fix: badge OPT. conservé + lignes vides purgées dans la table Blocs optionnels
- set_badge_para() : garde 'OPT.' stylé en run[0], ajoute le bullet
  en run plain séparé (plus de texte bullet dans la pastille orange)
- clear_para_runs() : supprime tous les runs des paragraphes vides
  (élimine le rectangle orange résiduel dans la 2e ligne non utilisée)
</commit_message>
<xml_diff>
--- a/assets/fiches/A1-fiche.pptx
+++ b/assets/fiches/A1-fiche.pptx
@@ -6043,16 +6043,6 @@
                           <a:spcPts val="254"/>
                         </a:spcBef>
                       </a:pPr>
-                      <a:r>
-                        <a:rPr sz="850" b="1" dirty="0">
-                          <a:solidFill>
-                            <a:srgbClr val="E67D21"/>
-                          </a:solidFill>
-                          <a:latin typeface="Arial"/>
-                          <a:cs typeface="Arial"/>
-                        </a:rPr>
-                        <a:t/>
-                      </a:r>
                       <a:endParaRPr sz="850">
                         <a:latin typeface="Arial"/>
                         <a:cs typeface="Arial"/>
@@ -6064,16 +6054,6 @@
                           <a:spcPts val="1200"/>
                         </a:lnSpc>
                       </a:pPr>
-                      <a:r>
-                        <a:rPr sz="1050" b="1" spc="-10" dirty="0">
-                          <a:solidFill>
-                            <a:srgbClr val="2B2B2B"/>
-                          </a:solidFill>
-                          <a:latin typeface="Arial"/>
-                          <a:cs typeface="Arial"/>
-                        </a:rPr>
-                        <a:t/>
-                      </a:r>
                       <a:endParaRPr sz="1050">
                         <a:latin typeface="Arial"/>
                         <a:cs typeface="Arial"/>
@@ -6091,16 +6071,6 @@
                           <a:tab pos="755015" algn="l"/>
                         </a:tabLst>
                       </a:pPr>
-                      <a:r>
-                        <a:rPr sz="1200" b="1" spc="-30" baseline="13888" dirty="0">
-                          <a:solidFill>
-                            <a:srgbClr val="FFFFFF"/>
-                          </a:solidFill>
-                          <a:latin typeface="Arial"/>
-                          <a:cs typeface="Arial"/>
-                        </a:rPr>
-                        <a:t/>
-                      </a:r>
                       <a:endParaRPr sz="900">
                         <a:latin typeface="Arial"/>
                         <a:cs typeface="Arial"/>
@@ -6112,16 +6082,6 @@
                           <a:spcPts val="1050"/>
                         </a:lnSpc>
                       </a:pPr>
-                      <a:r>
-                        <a:rPr sz="900" dirty="0">
-                          <a:solidFill>
-                            <a:srgbClr val="2B2B2B"/>
-                          </a:solidFill>
-                          <a:latin typeface="Arial"/>
-                          <a:cs typeface="Arial"/>
-                        </a:rPr>
-                        <a:t/>
-                      </a:r>
                       <a:endParaRPr sz="900">
                         <a:latin typeface="Arial"/>
                         <a:cs typeface="Arial"/>
@@ -6133,16 +6093,6 @@
                           <a:spcPts val="985"/>
                         </a:lnSpc>
                       </a:pPr>
-                      <a:r>
-                        <a:rPr sz="900" dirty="0">
-                          <a:solidFill>
-                            <a:srgbClr val="2B2B2B"/>
-                          </a:solidFill>
-                          <a:latin typeface="Arial"/>
-                          <a:cs typeface="Arial"/>
-                        </a:rPr>
-                        <a:t/>
-                      </a:r>
                       <a:endParaRPr sz="900">
                         <a:latin typeface="Arial"/>
                         <a:cs typeface="Arial"/>
@@ -6196,16 +6146,6 @@
                           <a:spcPts val="250"/>
                         </a:spcBef>
                       </a:pPr>
-                      <a:r>
-                        <a:rPr sz="850" b="1" dirty="0">
-                          <a:solidFill>
-                            <a:srgbClr val="E67D21"/>
-                          </a:solidFill>
-                          <a:latin typeface="Arial"/>
-                          <a:cs typeface="Arial"/>
-                        </a:rPr>
-                        <a:t/>
-                      </a:r>
                       <a:endParaRPr sz="850">
                         <a:latin typeface="Arial"/>
                         <a:cs typeface="Arial"/>
@@ -6217,16 +6157,6 @@
                           <a:spcPts val="1200"/>
                         </a:lnSpc>
                       </a:pPr>
-                      <a:r>
-                        <a:rPr sz="1050" b="1" dirty="0">
-                          <a:solidFill>
-                            <a:srgbClr val="2B2B2B"/>
-                          </a:solidFill>
-                          <a:latin typeface="Arial"/>
-                          <a:cs typeface="Arial"/>
-                        </a:rPr>
-                        <a:t/>
-                      </a:r>
                       <a:endParaRPr sz="1050">
                         <a:latin typeface="Arial"/>
                         <a:cs typeface="Arial"/>
@@ -6244,16 +6174,6 @@
                           <a:tab pos="524510" algn="l"/>
                         </a:tabLst>
                       </a:pPr>
-                      <a:r>
-                        <a:rPr sz="1200" b="1" spc="-30" baseline="13888" dirty="0">
-                          <a:solidFill>
-                            <a:srgbClr val="FFFFFF"/>
-                          </a:solidFill>
-                          <a:latin typeface="Arial"/>
-                          <a:cs typeface="Arial"/>
-                        </a:rPr>
-                        <a:t/>
-                      </a:r>
                       <a:endParaRPr sz="900">
                         <a:latin typeface="Arial"/>
                         <a:cs typeface="Arial"/>
@@ -6265,16 +6185,6 @@
                           <a:spcPts val="1050"/>
                         </a:lnSpc>
                       </a:pPr>
-                      <a:r>
-                        <a:rPr sz="900" dirty="0">
-                          <a:solidFill>
-                            <a:srgbClr val="2B2B2B"/>
-                          </a:solidFill>
-                          <a:latin typeface="Arial"/>
-                          <a:cs typeface="Arial"/>
-                        </a:rPr>
-                        <a:t/>
-                      </a:r>
                       <a:endParaRPr sz="900">
                         <a:latin typeface="Arial"/>
                         <a:cs typeface="Arial"/>
@@ -6286,16 +6196,6 @@
                           <a:spcPts val="885"/>
                         </a:lnSpc>
                       </a:pPr>
-                      <a:r>
-                        <a:rPr sz="900" dirty="0">
-                          <a:solidFill>
-                            <a:srgbClr val="2B2B2B"/>
-                          </a:solidFill>
-                          <a:latin typeface="Arial"/>
-                          <a:cs typeface="Arial"/>
-                        </a:rPr>
-                        <a:t/>
-                      </a:r>
                       <a:endParaRPr sz="900">
                         <a:latin typeface="Arial"/>
                         <a:cs typeface="Arial"/>

</xml_diff>

<commit_message>
fix: titre normAutofit + masquage bloc OPT quand aucune donnée
- set_norm_autofit() remplace spAutoFit par normAutofit sur object 2
  → le texte rétrécit au lieu de déborder sous la boîte titre
- hide_shape() déplace hors diapo object 48 (GROUP déco) et object 53
  (TABLE) quand optionnels est vide → aucun rectangle orange fantôme
- Regénère les 20 fiches avec les deux corrections
</commit_message>
<xml_diff>
--- a/assets/fiches/A1-fiche.pptx
+++ b/assets/fiches/A1-fiche.pptx
@@ -1475,7 +1475,7 @@
         </p:spPr>
         <p:txBody>
           <a:bodyPr vert="horz" wrap="square" lIns="0" tIns="12700" rIns="0" bIns="0" rtlCol="0">
-            <a:spAutoFit/>
+            <a:normAutofit/>
           </a:bodyPr>
           <a:lstStyle/>
           <a:p>
@@ -1519,7 +1519,7 @@
                 <a:latin typeface="Arial"/>
                 <a:cs typeface="Arial"/>
               </a:rPr>
-              <a:t>1h58 | Guide d'animation pour les Conseillers Numériques CD47</a:t>
+              <a:t>1h58 | Guide d'animation — Conseillers Numériques CD47</a:t>
             </a:r>
             <a:endParaRPr sz="1050">
               <a:latin typeface="Arial"/>
@@ -5357,7 +5357,7 @@
         </p:nvGrpSpPr>
         <p:grpSpPr>
           <a:xfrm>
-            <a:off x="533400" y="8101200"/>
+            <a:off x="-10000000" y="8101200"/>
             <a:ext cx="6489700" cy="1422400"/>
             <a:chOff x="533400" y="8101200"/>
             <a:chExt cx="6489700" cy="1422400"/>
@@ -5765,7 +5765,7 @@
           <p:nvPr/>
         </p:nvGraphicFramePr>
         <p:xfrm>
-          <a:off x="533400" y="7868790"/>
+          <a:off x="-10000000" y="7868790"/>
           <a:ext cx="6457950" cy="1663063"/>
         </p:xfrm>
         <a:graphic>
@@ -6043,6 +6043,36 @@
                           <a:spcPts val="254"/>
                         </a:spcBef>
                       </a:pPr>
+                      <a:r>
+                        <a:rPr sz="850" b="1" dirty="0">
+                          <a:solidFill>
+                            <a:srgbClr val="E67D21"/>
+                          </a:solidFill>
+                          <a:latin typeface="Arial"/>
+                          <a:cs typeface="Arial"/>
+                        </a:rPr>
+                        <a:t>15</a:t>
+                      </a:r>
+                      <a:r>
+                        <a:rPr sz="850" b="1" spc="-10" dirty="0">
+                          <a:solidFill>
+                            <a:srgbClr val="E67D21"/>
+                          </a:solidFill>
+                          <a:latin typeface="Arial"/>
+                          <a:cs typeface="Arial"/>
+                        </a:rPr>
+                        <a:t> </a:t>
+                      </a:r>
+                      <a:r>
+                        <a:rPr sz="850" b="1" spc="-25" dirty="0">
+                          <a:solidFill>
+                            <a:srgbClr val="E67D21"/>
+                          </a:solidFill>
+                          <a:latin typeface="Arial"/>
+                          <a:cs typeface="Arial"/>
+                        </a:rPr>
+                        <a:t>min</a:t>
+                      </a:r>
                       <a:endParaRPr sz="850">
                         <a:latin typeface="Arial"/>
                         <a:cs typeface="Arial"/>
@@ -6054,6 +6084,16 @@
                           <a:spcPts val="1200"/>
                         </a:lnSpc>
                       </a:pPr>
+                      <a:r>
+                        <a:rPr sz="1050" b="1" spc="-10" dirty="0">
+                          <a:solidFill>
+                            <a:srgbClr val="2B2B2B"/>
+                          </a:solidFill>
+                          <a:latin typeface="Arial"/>
+                          <a:cs typeface="Arial"/>
+                        </a:rPr>
+                        <a:t>Teleconsultation</a:t>
+                      </a:r>
                       <a:endParaRPr sz="1050">
                         <a:latin typeface="Arial"/>
                         <a:cs typeface="Arial"/>
@@ -6071,6 +6111,146 @@
                           <a:tab pos="755015" algn="l"/>
                         </a:tabLst>
                       </a:pPr>
+                      <a:r>
+                        <a:rPr sz="1200" b="1" spc="-30" baseline="13888" dirty="0">
+                          <a:solidFill>
+                            <a:srgbClr val="FFFFFF"/>
+                          </a:solidFill>
+                          <a:latin typeface="Arial"/>
+                          <a:cs typeface="Arial"/>
+                        </a:rPr>
+                        <a:t>OPT.</a:t>
+                      </a:r>
+                      <a:r>
+                        <a:rPr sz="1200" b="1" baseline="13888" dirty="0">
+                          <a:solidFill>
+                            <a:srgbClr val="FFFFFF"/>
+                          </a:solidFill>
+                          <a:latin typeface="Arial"/>
+                          <a:cs typeface="Arial"/>
+                        </a:rPr>
+                        <a:t>	</a:t>
+                      </a:r>
+                      <a:r>
+                        <a:rPr sz="900" dirty="0">
+                          <a:solidFill>
+                            <a:srgbClr val="2B2B2B"/>
+                          </a:solidFill>
+                          <a:latin typeface="Arial"/>
+                          <a:cs typeface="Arial"/>
+                        </a:rPr>
+                        <a:t>.</a:t>
+                      </a:r>
+                      <a:r>
+                        <a:rPr sz="900" spc="-5" dirty="0">
+                          <a:solidFill>
+                            <a:srgbClr val="2B2B2B"/>
+                          </a:solidFill>
+                          <a:latin typeface="Arial"/>
+                          <a:cs typeface="Arial"/>
+                        </a:rPr>
+                        <a:t> </a:t>
+                      </a:r>
+                      <a:r>
+                        <a:rPr sz="900" dirty="0">
+                          <a:solidFill>
+                            <a:srgbClr val="2B2B2B"/>
+                          </a:solidFill>
+                          <a:latin typeface="Arial"/>
+                          <a:cs typeface="Arial"/>
+                        </a:rPr>
+                        <a:t>Expliquer</a:t>
+                      </a:r>
+                      <a:r>
+                        <a:rPr sz="900" spc="-5" dirty="0">
+                          <a:solidFill>
+                            <a:srgbClr val="2B2B2B"/>
+                          </a:solidFill>
+                          <a:latin typeface="Arial"/>
+                          <a:cs typeface="Arial"/>
+                        </a:rPr>
+                        <a:t> </a:t>
+                      </a:r>
+                      <a:r>
+                        <a:rPr sz="900" dirty="0">
+                          <a:solidFill>
+                            <a:srgbClr val="2B2B2B"/>
+                          </a:solidFill>
+                          <a:latin typeface="Arial"/>
+                          <a:cs typeface="Arial"/>
+                        </a:rPr>
+                        <a:t>ce qu'est</a:t>
+                      </a:r>
+                      <a:r>
+                        <a:rPr sz="900" spc="-5" dirty="0">
+                          <a:solidFill>
+                            <a:srgbClr val="2B2B2B"/>
+                          </a:solidFill>
+                          <a:latin typeface="Arial"/>
+                          <a:cs typeface="Arial"/>
+                        </a:rPr>
+                        <a:t> </a:t>
+                      </a:r>
+                      <a:r>
+                        <a:rPr sz="900" dirty="0">
+                          <a:solidFill>
+                            <a:srgbClr val="2B2B2B"/>
+                          </a:solidFill>
+                          <a:latin typeface="Arial"/>
+                          <a:cs typeface="Arial"/>
+                        </a:rPr>
+                        <a:t>la teleconsultation</a:t>
+                      </a:r>
+                      <a:r>
+                        <a:rPr sz="900" spc="-5" dirty="0">
+                          <a:solidFill>
+                            <a:srgbClr val="2B2B2B"/>
+                          </a:solidFill>
+                          <a:latin typeface="Arial"/>
+                          <a:cs typeface="Arial"/>
+                        </a:rPr>
+                        <a:t> </a:t>
+                      </a:r>
+                      <a:r>
+                        <a:rPr sz="900" dirty="0">
+                          <a:solidFill>
+                            <a:srgbClr val="2B2B2B"/>
+                          </a:solidFill>
+                          <a:latin typeface="Arial"/>
+                          <a:cs typeface="Arial"/>
+                        </a:rPr>
+                        <a:t>et</a:t>
+                      </a:r>
+                      <a:r>
+                        <a:rPr sz="900" spc="-5" dirty="0">
+                          <a:solidFill>
+                            <a:srgbClr val="2B2B2B"/>
+                          </a:solidFill>
+                          <a:latin typeface="Arial"/>
+                          <a:cs typeface="Arial"/>
+                        </a:rPr>
+                        <a:t> </a:t>
+                      </a:r>
+                      <a:r>
+                        <a:rPr sz="900" dirty="0">
+                          <a:solidFill>
+                            <a:srgbClr val="2B2B2B"/>
+                          </a:solidFill>
+                          <a:latin typeface="Arial"/>
+                          <a:cs typeface="Arial"/>
+                        </a:rPr>
+                        <a:t>son </a:t>
+                      </a:r>
+                      <a:r>
+                        <a:rPr sz="900" spc="-10" dirty="0">
+                          <a:solidFill>
+                            <a:srgbClr val="2B2B2B"/>
+                          </a:solidFill>
+                          <a:latin typeface="Arial"/>
+                          <a:cs typeface="Arial"/>
+                        </a:rPr>
+                        <a:t>remboursement</a:t>
+                      </a:r>
                       <a:endParaRPr sz="900">
                         <a:latin typeface="Arial"/>
                         <a:cs typeface="Arial"/>
@@ -6082,6 +6262,26 @@
                           <a:spcPts val="1050"/>
                         </a:lnSpc>
                       </a:pPr>
+                      <a:r>
+                        <a:rPr sz="900" dirty="0">
+                          <a:solidFill>
+                            <a:srgbClr val="2B2B2B"/>
+                          </a:solidFill>
+                          <a:latin typeface="Arial"/>
+                          <a:cs typeface="Arial"/>
+                        </a:rPr>
+                        <a:t>. Montrer comment reperer un medecin proposant la </a:t>
+                      </a:r>
+                      <a:r>
+                        <a:rPr sz="900" spc="-10" dirty="0">
+                          <a:solidFill>
+                            <a:srgbClr val="2B2B2B"/>
+                          </a:solidFill>
+                          <a:latin typeface="Arial"/>
+                          <a:cs typeface="Arial"/>
+                        </a:rPr>
+                        <a:t>video</a:t>
+                      </a:r>
                       <a:endParaRPr sz="900">
                         <a:latin typeface="Arial"/>
                         <a:cs typeface="Arial"/>
@@ -6093,6 +6293,26 @@
                           <a:spcPts val="985"/>
                         </a:lnSpc>
                       </a:pPr>
+                      <a:r>
+                        <a:rPr sz="900" dirty="0">
+                          <a:solidFill>
+                            <a:srgbClr val="2B2B2B"/>
+                          </a:solidFill>
+                          <a:latin typeface="Arial"/>
+                          <a:cs typeface="Arial"/>
+                        </a:rPr>
+                        <a:t>. Simuler la reception du lien et le demarrage de la </a:t>
+                      </a:r>
+                      <a:r>
+                        <a:rPr sz="900" spc="-10" dirty="0">
+                          <a:solidFill>
+                            <a:srgbClr val="2B2B2B"/>
+                          </a:solidFill>
+                          <a:latin typeface="Arial"/>
+                          <a:cs typeface="Arial"/>
+                        </a:rPr>
+                        <a:t>session</a:t>
+                      </a:r>
                       <a:endParaRPr sz="900">
                         <a:latin typeface="Arial"/>
                         <a:cs typeface="Arial"/>
@@ -6146,6 +6366,36 @@
                           <a:spcPts val="250"/>
                         </a:spcBef>
                       </a:pPr>
+                      <a:r>
+                        <a:rPr sz="850" b="1" dirty="0">
+                          <a:solidFill>
+                            <a:srgbClr val="E67D21"/>
+                          </a:solidFill>
+                          <a:latin typeface="Arial"/>
+                          <a:cs typeface="Arial"/>
+                        </a:rPr>
+                        <a:t>10</a:t>
+                      </a:r>
+                      <a:r>
+                        <a:rPr sz="850" b="1" spc="-10" dirty="0">
+                          <a:solidFill>
+                            <a:srgbClr val="E67D21"/>
+                          </a:solidFill>
+                          <a:latin typeface="Arial"/>
+                          <a:cs typeface="Arial"/>
+                        </a:rPr>
+                        <a:t> </a:t>
+                      </a:r>
+                      <a:r>
+                        <a:rPr sz="850" b="1" spc="-25" dirty="0">
+                          <a:solidFill>
+                            <a:srgbClr val="E67D21"/>
+                          </a:solidFill>
+                          <a:latin typeface="Arial"/>
+                          <a:cs typeface="Arial"/>
+                        </a:rPr>
+                        <a:t>min</a:t>
+                      </a:r>
                       <a:endParaRPr sz="850">
                         <a:latin typeface="Arial"/>
                         <a:cs typeface="Arial"/>
@@ -6157,6 +6407,76 @@
                           <a:spcPts val="1200"/>
                         </a:lnSpc>
                       </a:pPr>
+                      <a:r>
+                        <a:rPr sz="1050" b="1" dirty="0">
+                          <a:solidFill>
+                            <a:srgbClr val="2B2B2B"/>
+                          </a:solidFill>
+                          <a:latin typeface="Arial"/>
+                          <a:cs typeface="Arial"/>
+                        </a:rPr>
+                        <a:t>Acceder</a:t>
+                      </a:r>
+                      <a:r>
+                        <a:rPr sz="1050" b="1" spc="-25" dirty="0">
+                          <a:solidFill>
+                            <a:srgbClr val="2B2B2B"/>
+                          </a:solidFill>
+                          <a:latin typeface="Arial"/>
+                          <a:cs typeface="Arial"/>
+                        </a:rPr>
+                        <a:t> </a:t>
+                      </a:r>
+                      <a:r>
+                        <a:rPr sz="1050" b="1" dirty="0">
+                          <a:solidFill>
+                            <a:srgbClr val="2B2B2B"/>
+                          </a:solidFill>
+                          <a:latin typeface="Arial"/>
+                          <a:cs typeface="Arial"/>
+                        </a:rPr>
+                        <a:t>a</a:t>
+                      </a:r>
+                      <a:r>
+                        <a:rPr sz="1050" b="1" spc="-25" dirty="0">
+                          <a:solidFill>
+                            <a:srgbClr val="2B2B2B"/>
+                          </a:solidFill>
+                          <a:latin typeface="Arial"/>
+                          <a:cs typeface="Arial"/>
+                        </a:rPr>
+                        <a:t> </a:t>
+                      </a:r>
+                      <a:r>
+                        <a:rPr sz="1050" b="1" dirty="0">
+                          <a:solidFill>
+                            <a:srgbClr val="2B2B2B"/>
+                          </a:solidFill>
+                          <a:latin typeface="Arial"/>
+                          <a:cs typeface="Arial"/>
+                        </a:rPr>
+                        <a:t>mes</a:t>
+                      </a:r>
+                      <a:r>
+                        <a:rPr sz="1050" b="1" spc="-20" dirty="0">
+                          <a:solidFill>
+                            <a:srgbClr val="2B2B2B"/>
+                          </a:solidFill>
+                          <a:latin typeface="Arial"/>
+                          <a:cs typeface="Arial"/>
+                        </a:rPr>
+                        <a:t> </a:t>
+                      </a:r>
+                      <a:r>
+                        <a:rPr sz="1050" b="1" spc="-10" dirty="0">
+                          <a:solidFill>
+                            <a:srgbClr val="2B2B2B"/>
+                          </a:solidFill>
+                          <a:latin typeface="Arial"/>
+                          <a:cs typeface="Arial"/>
+                        </a:rPr>
+                        <a:t>documents</a:t>
+                      </a:r>
                       <a:endParaRPr sz="1050">
                         <a:latin typeface="Arial"/>
                         <a:cs typeface="Arial"/>
@@ -6174,6 +6494,46 @@
                           <a:tab pos="524510" algn="l"/>
                         </a:tabLst>
                       </a:pPr>
+                      <a:r>
+                        <a:rPr sz="1200" b="1" spc="-30" baseline="13888" dirty="0">
+                          <a:solidFill>
+                            <a:srgbClr val="FFFFFF"/>
+                          </a:solidFill>
+                          <a:latin typeface="Arial"/>
+                          <a:cs typeface="Arial"/>
+                        </a:rPr>
+                        <a:t>OPT.</a:t>
+                      </a:r>
+                      <a:r>
+                        <a:rPr sz="1200" b="1" baseline="13888" dirty="0">
+                          <a:solidFill>
+                            <a:srgbClr val="FFFFFF"/>
+                          </a:solidFill>
+                          <a:latin typeface="Arial"/>
+                          <a:cs typeface="Arial"/>
+                        </a:rPr>
+                        <a:t>	</a:t>
+                      </a:r>
+                      <a:r>
+                        <a:rPr sz="900" dirty="0">
+                          <a:solidFill>
+                            <a:srgbClr val="2B2B2B"/>
+                          </a:solidFill>
+                          <a:latin typeface="Arial"/>
+                          <a:cs typeface="Arial"/>
+                        </a:rPr>
+                        <a:t>. Naviguer vers Mon espace sante &gt; Mes </a:t>
+                      </a:r>
+                      <a:r>
+                        <a:rPr sz="900" spc="-10" dirty="0">
+                          <a:solidFill>
+                            <a:srgbClr val="2B2B2B"/>
+                          </a:solidFill>
+                          <a:latin typeface="Arial"/>
+                          <a:cs typeface="Arial"/>
+                        </a:rPr>
+                        <a:t>documents</a:t>
+                      </a:r>
                       <a:endParaRPr sz="900">
                         <a:latin typeface="Arial"/>
                         <a:cs typeface="Arial"/>
@@ -6185,6 +6545,26 @@
                           <a:spcPts val="1050"/>
                         </a:lnSpc>
                       </a:pPr>
+                      <a:r>
+                        <a:rPr sz="900" dirty="0">
+                          <a:solidFill>
+                            <a:srgbClr val="2B2B2B"/>
+                          </a:solidFill>
+                          <a:latin typeface="Arial"/>
+                          <a:cs typeface="Arial"/>
+                        </a:rPr>
+                        <a:t>. Retrouver une ordonnance ou un resultat </a:t>
+                      </a:r>
+                      <a:r>
+                        <a:rPr sz="900" spc="-10" dirty="0">
+                          <a:solidFill>
+                            <a:srgbClr val="2B2B2B"/>
+                          </a:solidFill>
+                          <a:latin typeface="Arial"/>
+                          <a:cs typeface="Arial"/>
+                        </a:rPr>
+                        <a:t>d'analyse</a:t>
+                      </a:r>
                       <a:endParaRPr sz="900">
                         <a:latin typeface="Arial"/>
                         <a:cs typeface="Arial"/>
@@ -6196,6 +6576,26 @@
                           <a:spcPts val="885"/>
                         </a:lnSpc>
                       </a:pPr>
+                      <a:r>
+                        <a:rPr sz="900" dirty="0">
+                          <a:solidFill>
+                            <a:srgbClr val="2B2B2B"/>
+                          </a:solidFill>
+                          <a:latin typeface="Arial"/>
+                          <a:cs typeface="Arial"/>
+                        </a:rPr>
+                        <a:t>. Telecharger ou imprimer un document depuis </a:t>
+                      </a:r>
+                      <a:r>
+                        <a:rPr sz="900" spc="-10" dirty="0">
+                          <a:solidFill>
+                            <a:srgbClr val="2B2B2B"/>
+                          </a:solidFill>
+                          <a:latin typeface="Arial"/>
+                          <a:cs typeface="Arial"/>
+                        </a:rPr>
+                        <a:t>Doctolib</a:t>
+                      </a:r>
                       <a:endParaRPr sz="900">
                         <a:latin typeface="Arial"/>
                         <a:cs typeface="Arial"/>

</xml_diff>

<commit_message>
fix: titre simplifié + bloc OPT vraiment dynamique
- para[0] = nom atelier uniquement (fini le wrap sur 2 lignes)
- para[1] = "Fiche Action | durée | Guide d'animation..."
- clear_table_row() efface aussi le fond de cellule tcPr (supprime
  le rectangle orange résiduel dans la ligne OPT vide)
- object 48 GROUP toujours masqué (impossible de cibler ses enfants
  individuellement, le tableau seul suffit)
- Regénère les 20 fiches
</commit_message>
<xml_diff>
--- a/assets/fiches/A1-fiche.pptx
+++ b/assets/fiches/A1-fiche.pptx
@@ -1495,7 +1495,7 @@
                 <a:latin typeface="Arial"/>
                 <a:cs typeface="Arial"/>
               </a:rPr>
-              <a:t>Fiche Action - Atelier Prendre en main l'ordinateur</a:t>
+              <a:t>Prendre en main l'ordinateur</a:t>
             </a:r>
             <a:endParaRPr sz="2000">
               <a:latin typeface="Arial"/>
@@ -1519,7 +1519,7 @@
                 <a:latin typeface="Arial"/>
                 <a:cs typeface="Arial"/>
               </a:rPr>
-              <a:t>1h58 | Guide d'animation — Conseillers Numériques CD47</a:t>
+              <a:t>Fiche Action | 1h58 | Guide d'animation — Conseillers Numériques CD47</a:t>
             </a:r>
             <a:endParaRPr sz="1050">
               <a:latin typeface="Arial"/>

</xml_diff>